<commit_message>
fix: preserve validation id through PDF preview
</commit_message>
<xml_diff>
--- a/codebase/reference/demo-slides-source.pptx
+++ b/codebase/reference/demo-slides-source.pptx
@@ -2,18 +2,18 @@
 <file path=ppt/presentation.xml><?xml version="1.0" encoding="utf-8"?>
 <p:presentation xmlns:p="http://schemas.openxmlformats.org/presentationml/2006/main">
   <p:sldMasterIdLst>
-    <p:sldMasterId xmlns:r="http://schemas.openxmlformats.org/officeDocument/2006/relationships" id="2147483648" r:id="R1e741e4608cf464b"/>
+    <p:sldMasterId xmlns:r="http://schemas.openxmlformats.org/officeDocument/2006/relationships" id="2147483648" r:id="Rb81aef688d1740c6"/>
   </p:sldMasterIdLst>
   <p:notesMasterIdLst>
-    <p:notesMasterId xmlns:r="http://schemas.openxmlformats.org/officeDocument/2006/relationships" r:id="Rc97a0c9be6ca498d"/>
+    <p:notesMasterId xmlns:r="http://schemas.openxmlformats.org/officeDocument/2006/relationships" r:id="R772b8c607efb4b91"/>
   </p:notesMasterIdLst>
   <p:sldIdLst>
-    <p:sldId xmlns:r="http://schemas.openxmlformats.org/officeDocument/2006/relationships" id="256" r:id="R2f013e2c44564c9d"/>
-    <p:sldId xmlns:r="http://schemas.openxmlformats.org/officeDocument/2006/relationships" id="257" r:id="R41788a5edd4543d5"/>
-    <p:sldId xmlns:r="http://schemas.openxmlformats.org/officeDocument/2006/relationships" id="258" r:id="R20fe18502acb44e5"/>
-    <p:sldId xmlns:r="http://schemas.openxmlformats.org/officeDocument/2006/relationships" id="259" r:id="R5167ee0fbdf84973"/>
-    <p:sldId xmlns:r="http://schemas.openxmlformats.org/officeDocument/2006/relationships" id="260" r:id="R6a9ee2a4e45b4ca8"/>
-    <p:sldId xmlns:r="http://schemas.openxmlformats.org/officeDocument/2006/relationships" id="261" r:id="R2bee3f403b004471"/>
+    <p:sldId xmlns:r="http://schemas.openxmlformats.org/officeDocument/2006/relationships" id="256" r:id="R463fe210f88a4920"/>
+    <p:sldId xmlns:r="http://schemas.openxmlformats.org/officeDocument/2006/relationships" id="257" r:id="R7f9fb2fdbd9541e9"/>
+    <p:sldId xmlns:r="http://schemas.openxmlformats.org/officeDocument/2006/relationships" id="258" r:id="Rc46ca8c540164075"/>
+    <p:sldId xmlns:r="http://schemas.openxmlformats.org/officeDocument/2006/relationships" id="259" r:id="Rb5d4c8f984194837"/>
+    <p:sldId xmlns:r="http://schemas.openxmlformats.org/officeDocument/2006/relationships" id="260" r:id="R30b93dfa98074e43"/>
+    <p:sldId xmlns:r="http://schemas.openxmlformats.org/officeDocument/2006/relationships" id="261" r:id="R1da1a553bc6942f5"/>
   </p:sldIdLst>
   <p:sldSz cx="12192000" cy="6858000"/>
   <p:notesSz cx="6858000" cy="9144000"/>
@@ -1015,7 +1015,7 @@
   </p:cSld>
   <p:clrMap bg1="lt1" tx1="dk1" bg2="lt2" tx2="dk2" accent1="accent1" accent2="accent2" accent3="accent3" accent4="accent4" accent5="accent5" accent6="accent6" hlink="hlink" folHlink="folHlink"/>
   <p:sldLayoutIdLst>
-    <p:sldLayoutId xmlns:r="http://schemas.openxmlformats.org/officeDocument/2006/relationships" id="2147483649" r:id="R44ccdb6b42b240d9"/>
+    <p:sldLayoutId xmlns:r="http://schemas.openxmlformats.org/officeDocument/2006/relationships" id="2147483649" r:id="R3260721015f14c51"/>
   </p:sldLayoutIdLst>
   <p:txStyles>
     <p:titleStyle>
@@ -1559,7 +1559,7 @@
           <p:cNvPr id="4" name="Title-3-1">
             <a:extLst xmlns:a="http://schemas.openxmlformats.org/drawingml/2006/main">
               <a:ext uri="{FF2B5EF4-FFF2-40B4-BE49-F238E27FC236}">
-                <a16:creationId xmlns:a16="http://schemas.microsoft.com/office/drawing/2014/main" id="{CBF377AA-9A32-4665-94B9-4810C19FF91F}"/>
+                <a16:creationId xmlns:a16="http://schemas.microsoft.com/office/drawing/2014/main" id="{774807FB-168A-4A05-B6F1-CA01087F3492}"/>
               </a:ext>
             </a:extLst>
           </p:cNvPr>
@@ -1605,7 +1605,7 @@
           <p:cNvPr id="2" name="Subtitle-4-2">
             <a:extLst xmlns:a="http://schemas.openxmlformats.org/drawingml/2006/main">
               <a:ext uri="{FF2B5EF4-FFF2-40B4-BE49-F238E27FC236}">
-                <a16:creationId xmlns:a16="http://schemas.microsoft.com/office/drawing/2014/main" id="{DF2C947A-D7BF-49BA-A7A8-21B824875FE4}"/>
+                <a16:creationId xmlns:a16="http://schemas.microsoft.com/office/drawing/2014/main" id="{373F6C4F-BCCC-4876-84FB-CE9C2E38DABC}"/>
               </a:ext>
             </a:extLst>
           </p:cNvPr>
@@ -1650,7 +1650,7 @@
           <p:cNvPr id="3" name="Subtitle-4-3">
             <a:extLst xmlns:a="http://schemas.openxmlformats.org/drawingml/2006/main">
               <a:ext uri="{FF2B5EF4-FFF2-40B4-BE49-F238E27FC236}">
-                <a16:creationId xmlns:a16="http://schemas.microsoft.com/office/drawing/2014/main" id="{DFA278DD-8B32-4665-B95E-F3C2120568E4}"/>
+                <a16:creationId xmlns:a16="http://schemas.microsoft.com/office/drawing/2014/main" id="{6E635359-78B2-4B76-9674-CB82DDC5BDF3}"/>
               </a:ext>
             </a:extLst>
           </p:cNvPr>
@@ -1693,7 +1693,7 @@
     </p:spTree>
     <p:extLst>
       <p:ext uri="{BB962C8B-B14F-4D97-AF65-F5344CB8AC3E}">
-        <p14:creationId xmlns:p14="http://schemas.microsoft.com/office/powerpoint/2010/main" val="1406506808"/>
+        <p14:creationId xmlns:p14="http://schemas.microsoft.com/office/powerpoint/2010/main" val="904841640"/>
       </p:ext>
     </p:extLst>
   </p:cSld>
@@ -1717,7 +1717,7 @@
           <p:cNvPr id="13" name="Rounded-Rectangle-5-1">
             <a:extLst xmlns:a="http://schemas.openxmlformats.org/drawingml/2006/main">
               <a:ext uri="{FF2B5EF4-FFF2-40B4-BE49-F238E27FC236}">
-                <a16:creationId xmlns:a16="http://schemas.microsoft.com/office/drawing/2014/main" id="{B8D259CF-2D7E-4865-9E62-D2C7AC3E699C}"/>
+                <a16:creationId xmlns:a16="http://schemas.microsoft.com/office/drawing/2014/main" id="{3005741E-D7E4-4420-8582-2350DA28F212}"/>
               </a:ext>
             </a:extLst>
           </p:cNvPr>
@@ -1746,7 +1746,7 @@
           <p:cNvPr id="2" name="Rounded-Rectangle-6-2">
             <a:extLst xmlns:a="http://schemas.openxmlformats.org/drawingml/2006/main">
               <a:ext uri="{FF2B5EF4-FFF2-40B4-BE49-F238E27FC236}">
-                <a16:creationId xmlns:a16="http://schemas.microsoft.com/office/drawing/2014/main" id="{4B586F3B-EC44-4A03-9BE1-AEE3B8FDC8AC}"/>
+                <a16:creationId xmlns:a16="http://schemas.microsoft.com/office/drawing/2014/main" id="{150F0691-C415-43D1-A8B2-9387ABEB3CE1}"/>
               </a:ext>
             </a:extLst>
           </p:cNvPr>
@@ -1775,7 +1775,7 @@
           <p:cNvPr id="3" name="Rounded-Rectangle-7-3">
             <a:extLst xmlns:a="http://schemas.openxmlformats.org/drawingml/2006/main">
               <a:ext uri="{FF2B5EF4-FFF2-40B4-BE49-F238E27FC236}">
-                <a16:creationId xmlns:a16="http://schemas.microsoft.com/office/drawing/2014/main" id="{D5C042B2-678A-40F8-97EE-399D2D16F131}"/>
+                <a16:creationId xmlns:a16="http://schemas.microsoft.com/office/drawing/2014/main" id="{66B7A448-1FBB-4343-B88B-7D1201F11FEF}"/>
               </a:ext>
             </a:extLst>
           </p:cNvPr>
@@ -1804,7 +1804,7 @@
           <p:cNvPr id="4" name="Slide-Number-Placeholder-1-4">
             <a:extLst xmlns:a="http://schemas.openxmlformats.org/drawingml/2006/main">
               <a:ext uri="{FF2B5EF4-FFF2-40B4-BE49-F238E27FC236}">
-                <a16:creationId xmlns:a16="http://schemas.microsoft.com/office/drawing/2014/main" id="{CACF7636-E64A-469F-8998-C6AC22E80D48}"/>
+                <a16:creationId xmlns:a16="http://schemas.microsoft.com/office/drawing/2014/main" id="{163F1A54-166E-41CD-8F44-9A7E78BAA5B6}"/>
               </a:ext>
             </a:extLst>
           </p:cNvPr>
@@ -1847,7 +1847,7 @@
           <p:cNvPr id="5" name="Title-2-5">
             <a:extLst xmlns:a="http://schemas.openxmlformats.org/drawingml/2006/main">
               <a:ext uri="{FF2B5EF4-FFF2-40B4-BE49-F238E27FC236}">
-                <a16:creationId xmlns:a16="http://schemas.microsoft.com/office/drawing/2014/main" id="{88C96EBF-89C4-43A9-9A72-529370B69128}"/>
+                <a16:creationId xmlns:a16="http://schemas.microsoft.com/office/drawing/2014/main" id="{76F8127F-57E8-44CE-8CD3-D52CFA5F5F02}"/>
               </a:ext>
             </a:extLst>
           </p:cNvPr>
@@ -1892,7 +1892,7 @@
           <p:cNvPr id="6" name="Content-Placeholder-9-6">
             <a:extLst xmlns:a="http://schemas.openxmlformats.org/drawingml/2006/main">
               <a:ext uri="{FF2B5EF4-FFF2-40B4-BE49-F238E27FC236}">
-                <a16:creationId xmlns:a16="http://schemas.microsoft.com/office/drawing/2014/main" id="{1C7EFB9A-6624-475C-9737-0EED61AB22FD}"/>
+                <a16:creationId xmlns:a16="http://schemas.microsoft.com/office/drawing/2014/main" id="{7E161122-2A90-491B-AF69-A54099AED875}"/>
               </a:ext>
             </a:extLst>
           </p:cNvPr>
@@ -1937,7 +1937,7 @@
           <p:cNvPr id="7" name="Content-Placeholder-10-7">
             <a:extLst xmlns:a="http://schemas.openxmlformats.org/drawingml/2006/main">
               <a:ext uri="{FF2B5EF4-FFF2-40B4-BE49-F238E27FC236}">
-                <a16:creationId xmlns:a16="http://schemas.microsoft.com/office/drawing/2014/main" id="{B454F976-9249-4979-9AF5-C2C997237BF3}"/>
+                <a16:creationId xmlns:a16="http://schemas.microsoft.com/office/drawing/2014/main" id="{6E3A7459-50DE-4720-961A-4FE461EFACCB}"/>
               </a:ext>
             </a:extLst>
           </p:cNvPr>
@@ -1982,7 +1982,7 @@
           <p:cNvPr id="8" name="Content-Placeholder-11-8">
             <a:extLst xmlns:a="http://schemas.openxmlformats.org/drawingml/2006/main">
               <a:ext uri="{FF2B5EF4-FFF2-40B4-BE49-F238E27FC236}">
-                <a16:creationId xmlns:a16="http://schemas.microsoft.com/office/drawing/2014/main" id="{F46AD690-EE41-4F25-AA1A-53C69E56E7F9}"/>
+                <a16:creationId xmlns:a16="http://schemas.microsoft.com/office/drawing/2014/main" id="{CFC2823E-24EC-4D7C-9B6D-864B470FBA08}"/>
               </a:ext>
             </a:extLst>
           </p:cNvPr>
@@ -2027,7 +2027,7 @@
           <p:cNvPr id="9" name="Content-Placeholder-9-9">
             <a:extLst xmlns:a="http://schemas.openxmlformats.org/drawingml/2006/main">
               <a:ext uri="{FF2B5EF4-FFF2-40B4-BE49-F238E27FC236}">
-                <a16:creationId xmlns:a16="http://schemas.microsoft.com/office/drawing/2014/main" id="{9C4C6887-ED71-4723-A649-D6298D8FB4FF}"/>
+                <a16:creationId xmlns:a16="http://schemas.microsoft.com/office/drawing/2014/main" id="{8776C1D6-A7CB-4559-99BA-6428ABFACDB3}"/>
               </a:ext>
             </a:extLst>
           </p:cNvPr>
@@ -2072,7 +2072,7 @@
           <p:cNvPr id="10" name="Content-Placeholder-9-10">
             <a:extLst xmlns:a="http://schemas.openxmlformats.org/drawingml/2006/main">
               <a:ext uri="{FF2B5EF4-FFF2-40B4-BE49-F238E27FC236}">
-                <a16:creationId xmlns:a16="http://schemas.microsoft.com/office/drawing/2014/main" id="{5119CD4B-3F0C-4A22-9EA7-5968C887CD8E}"/>
+                <a16:creationId xmlns:a16="http://schemas.microsoft.com/office/drawing/2014/main" id="{B67008F3-B0A9-4B3C-8A07-58362509A3F6}"/>
               </a:ext>
             </a:extLst>
           </p:cNvPr>
@@ -2117,7 +2117,7 @@
           <p:cNvPr id="11" name="Content-Placeholder-9-11">
             <a:extLst xmlns:a="http://schemas.openxmlformats.org/drawingml/2006/main">
               <a:ext uri="{FF2B5EF4-FFF2-40B4-BE49-F238E27FC236}">
-                <a16:creationId xmlns:a16="http://schemas.microsoft.com/office/drawing/2014/main" id="{56B7C812-98FD-4C28-8240-B2FA1F8CC891}"/>
+                <a16:creationId xmlns:a16="http://schemas.microsoft.com/office/drawing/2014/main" id="{7E384708-D929-4D9E-B18C-E9082890364C}"/>
               </a:ext>
             </a:extLst>
           </p:cNvPr>
@@ -2162,7 +2162,7 @@
           <p:cNvPr id="12" name="Content-Placeholder-15-12">
             <a:extLst xmlns:a="http://schemas.openxmlformats.org/drawingml/2006/main">
               <a:ext uri="{FF2B5EF4-FFF2-40B4-BE49-F238E27FC236}">
-                <a16:creationId xmlns:a16="http://schemas.microsoft.com/office/drawing/2014/main" id="{AC926803-7876-44D0-8EF2-DFE12E6408F9}"/>
+                <a16:creationId xmlns:a16="http://schemas.microsoft.com/office/drawing/2014/main" id="{EFEC39B8-0B25-420F-8633-5B60E119BFFF}"/>
               </a:ext>
             </a:extLst>
           </p:cNvPr>
@@ -2220,7 +2220,7 @@
     </p:spTree>
     <p:extLst>
       <p:ext uri="{BB962C8B-B14F-4D97-AF65-F5344CB8AC3E}">
-        <p14:creationId xmlns:p14="http://schemas.microsoft.com/office/powerpoint/2010/main" val="852661310"/>
+        <p14:creationId xmlns:p14="http://schemas.microsoft.com/office/powerpoint/2010/main" val="197517484"/>
       </p:ext>
     </p:extLst>
   </p:cSld>
@@ -2244,7 +2244,7 @@
           <p:cNvPr id="13" name="Slide-Number-Placeholder-3-2">
             <a:extLst xmlns:a="http://schemas.openxmlformats.org/drawingml/2006/main">
               <a:ext uri="{FF2B5EF4-FFF2-40B4-BE49-F238E27FC236}">
-                <a16:creationId xmlns:a16="http://schemas.microsoft.com/office/drawing/2014/main" id="{F348FEEE-CDBD-4DA3-B277-979B9D606C6B}"/>
+                <a16:creationId xmlns:a16="http://schemas.microsoft.com/office/drawing/2014/main" id="{343C01DC-E4B3-47C5-B329-041EDA541BA0}"/>
               </a:ext>
             </a:extLst>
           </p:cNvPr>
@@ -2287,7 +2287,7 @@
           <p:cNvPr id="2" name="Title-10-3">
             <a:extLst xmlns:a="http://schemas.openxmlformats.org/drawingml/2006/main">
               <a:ext uri="{FF2B5EF4-FFF2-40B4-BE49-F238E27FC236}">
-                <a16:creationId xmlns:a16="http://schemas.microsoft.com/office/drawing/2014/main" id="{FB6122DB-4BC7-48FD-B4EE-38322AC3DFF6}"/>
+                <a16:creationId xmlns:a16="http://schemas.microsoft.com/office/drawing/2014/main" id="{F4125E8E-B3BF-41B8-BA9D-5BAD3EE5F4D3}"/>
               </a:ext>
             </a:extLst>
           </p:cNvPr>
@@ -2354,7 +2354,7 @@
           <p:cNvPr id="4" name="Google-Shape-2260-p159-5">
             <a:extLst xmlns:a="http://schemas.openxmlformats.org/drawingml/2006/main">
               <a:ext uri="{FF2B5EF4-FFF2-40B4-BE49-F238E27FC236}">
-                <a16:creationId xmlns:a16="http://schemas.microsoft.com/office/drawing/2014/main" id="{BEF94BB7-A363-4D37-A7B4-14BC3B555E35}"/>
+                <a16:creationId xmlns:a16="http://schemas.microsoft.com/office/drawing/2014/main" id="{0DEF28A8-3D16-4282-9D2C-7AF222245892}"/>
               </a:ext>
             </a:extLst>
           </p:cNvPr>
@@ -2381,7 +2381,7 @@
           <p:cNvPr id="5" name="Google-Shape-2261-p159-6">
             <a:extLst xmlns:a="http://schemas.openxmlformats.org/drawingml/2006/main">
               <a:ext uri="{FF2B5EF4-FFF2-40B4-BE49-F238E27FC236}">
-                <a16:creationId xmlns:a16="http://schemas.microsoft.com/office/drawing/2014/main" id="{6BC4C7BB-93C3-48B3-ABE0-9A30C4782469}"/>
+                <a16:creationId xmlns:a16="http://schemas.microsoft.com/office/drawing/2014/main" id="{D54BAF61-15F4-4FEB-B864-92B00D96E66A}"/>
               </a:ext>
             </a:extLst>
           </p:cNvPr>
@@ -2408,7 +2408,7 @@
           <p:cNvPr id="6" name="Google-Shape-2262-p159-7">
             <a:extLst xmlns:a="http://schemas.openxmlformats.org/drawingml/2006/main">
               <a:ext uri="{FF2B5EF4-FFF2-40B4-BE49-F238E27FC236}">
-                <a16:creationId xmlns:a16="http://schemas.microsoft.com/office/drawing/2014/main" id="{5A30A19D-E40F-4A28-A7D3-3CACCD84E801}"/>
+                <a16:creationId xmlns:a16="http://schemas.microsoft.com/office/drawing/2014/main" id="{5C3144BD-AB47-4B54-9437-4A17509EFE02}"/>
               </a:ext>
             </a:extLst>
           </p:cNvPr>
@@ -2435,7 +2435,7 @@
           <p:cNvPr id="7" name="Content-Placeholder-15-8">
             <a:extLst xmlns:a="http://schemas.openxmlformats.org/drawingml/2006/main">
               <a:ext uri="{FF2B5EF4-FFF2-40B4-BE49-F238E27FC236}">
-                <a16:creationId xmlns:a16="http://schemas.microsoft.com/office/drawing/2014/main" id="{853A5738-95E4-4313-9C04-EC42F67DA200}"/>
+                <a16:creationId xmlns:a16="http://schemas.microsoft.com/office/drawing/2014/main" id="{3930CF47-91C0-4717-B553-54AF2B9E8F07}"/>
               </a:ext>
             </a:extLst>
           </p:cNvPr>
@@ -2480,7 +2480,7 @@
           <p:cNvPr id="8" name="Content-Placeholder-15-9">
             <a:extLst xmlns:a="http://schemas.openxmlformats.org/drawingml/2006/main">
               <a:ext uri="{FF2B5EF4-FFF2-40B4-BE49-F238E27FC236}">
-                <a16:creationId xmlns:a16="http://schemas.microsoft.com/office/drawing/2014/main" id="{98890442-F4A6-45D4-98EF-DD0F3CE6419E}"/>
+                <a16:creationId xmlns:a16="http://schemas.microsoft.com/office/drawing/2014/main" id="{2EBF980C-A676-49DC-9A50-AAB5C2AA2E83}"/>
               </a:ext>
             </a:extLst>
           </p:cNvPr>
@@ -2525,7 +2525,7 @@
           <p:cNvPr id="9" name="Content-Placeholder-15-10">
             <a:extLst xmlns:a="http://schemas.openxmlformats.org/drawingml/2006/main">
               <a:ext uri="{FF2B5EF4-FFF2-40B4-BE49-F238E27FC236}">
-                <a16:creationId xmlns:a16="http://schemas.microsoft.com/office/drawing/2014/main" id="{D12AFB43-D00E-4E88-8A1B-323D9FD5DE86}"/>
+                <a16:creationId xmlns:a16="http://schemas.microsoft.com/office/drawing/2014/main" id="{8728A4B6-4005-4BAF-B873-11E56559E73A}"/>
               </a:ext>
             </a:extLst>
           </p:cNvPr>
@@ -2570,7 +2570,7 @@
           <p:cNvPr id="10" name="Text-Placeholder-16-11">
             <a:extLst xmlns:a="http://schemas.openxmlformats.org/drawingml/2006/main">
               <a:ext uri="{FF2B5EF4-FFF2-40B4-BE49-F238E27FC236}">
-                <a16:creationId xmlns:a16="http://schemas.microsoft.com/office/drawing/2014/main" id="{8520BA6F-FB39-4279-A8B7-597A9281B56C}"/>
+                <a16:creationId xmlns:a16="http://schemas.microsoft.com/office/drawing/2014/main" id="{941AA2CA-547E-4D2E-AD52-749A5025D520}"/>
               </a:ext>
             </a:extLst>
           </p:cNvPr>
@@ -2630,7 +2630,7 @@
           <p:cNvPr id="11" name="Text-Placeholder-16-12">
             <a:extLst xmlns:a="http://schemas.openxmlformats.org/drawingml/2006/main">
               <a:ext uri="{FF2B5EF4-FFF2-40B4-BE49-F238E27FC236}">
-                <a16:creationId xmlns:a16="http://schemas.microsoft.com/office/drawing/2014/main" id="{177CBFB6-06AB-4F03-B6A1-15BA8256718A}"/>
+                <a16:creationId xmlns:a16="http://schemas.microsoft.com/office/drawing/2014/main" id="{2B71D42C-556A-4D59-9917-E67F95976AC8}"/>
               </a:ext>
             </a:extLst>
           </p:cNvPr>
@@ -2690,7 +2690,7 @@
           <p:cNvPr id="12" name="Text-Placeholder-16-13">
             <a:extLst xmlns:a="http://schemas.openxmlformats.org/drawingml/2006/main">
               <a:ext uri="{FF2B5EF4-FFF2-40B4-BE49-F238E27FC236}">
-                <a16:creationId xmlns:a16="http://schemas.microsoft.com/office/drawing/2014/main" id="{7109DBB0-8145-4234-9447-82981ADCAE17}"/>
+                <a16:creationId xmlns:a16="http://schemas.microsoft.com/office/drawing/2014/main" id="{3BA42B70-462A-499F-A3F2-1825DFCAB93E}"/>
               </a:ext>
             </a:extLst>
           </p:cNvPr>
@@ -2748,7 +2748,7 @@
     </p:spTree>
     <p:extLst>
       <p:ext uri="{BB962C8B-B14F-4D97-AF65-F5344CB8AC3E}">
-        <p14:creationId xmlns:p14="http://schemas.microsoft.com/office/powerpoint/2010/main" val="1940525860"/>
+        <p14:creationId xmlns:p14="http://schemas.microsoft.com/office/powerpoint/2010/main" val="1449201615"/>
       </p:ext>
     </p:extLst>
   </p:cSld>
@@ -2772,7 +2772,7 @@
           <p:cNvPr id="13" name="Rounded-Rectangle-5-1">
             <a:extLst xmlns:a="http://schemas.openxmlformats.org/drawingml/2006/main">
               <a:ext uri="{FF2B5EF4-FFF2-40B4-BE49-F238E27FC236}">
-                <a16:creationId xmlns:a16="http://schemas.microsoft.com/office/drawing/2014/main" id="{54E6D11B-70B1-4C60-BD04-B0E9D13831F0}"/>
+                <a16:creationId xmlns:a16="http://schemas.microsoft.com/office/drawing/2014/main" id="{AB256EB1-5F3F-4BD5-BF42-F4428F7C27E4}"/>
               </a:ext>
             </a:extLst>
           </p:cNvPr>
@@ -2801,7 +2801,7 @@
           <p:cNvPr id="2" name="Rounded-Rectangle-6-2">
             <a:extLst xmlns:a="http://schemas.openxmlformats.org/drawingml/2006/main">
               <a:ext uri="{FF2B5EF4-FFF2-40B4-BE49-F238E27FC236}">
-                <a16:creationId xmlns:a16="http://schemas.microsoft.com/office/drawing/2014/main" id="{03CEDEE1-2A3C-419D-9E39-1C80A8799919}"/>
+                <a16:creationId xmlns:a16="http://schemas.microsoft.com/office/drawing/2014/main" id="{61B738C9-91CB-4775-8261-8B4A5FD85487}"/>
               </a:ext>
             </a:extLst>
           </p:cNvPr>
@@ -2830,7 +2830,7 @@
           <p:cNvPr id="3" name="Rounded-Rectangle-7-3">
             <a:extLst xmlns:a="http://schemas.openxmlformats.org/drawingml/2006/main">
               <a:ext uri="{FF2B5EF4-FFF2-40B4-BE49-F238E27FC236}">
-                <a16:creationId xmlns:a16="http://schemas.microsoft.com/office/drawing/2014/main" id="{68AD0EE1-2072-4C81-941E-8DDD9E866ADA}"/>
+                <a16:creationId xmlns:a16="http://schemas.microsoft.com/office/drawing/2014/main" id="{E6DBCB1A-E894-45FF-81F4-CCD564D2EE16}"/>
               </a:ext>
             </a:extLst>
           </p:cNvPr>
@@ -2859,7 +2859,7 @@
           <p:cNvPr id="4" name="Slide-Number-Placeholder-1-4">
             <a:extLst xmlns:a="http://schemas.openxmlformats.org/drawingml/2006/main">
               <a:ext uri="{FF2B5EF4-FFF2-40B4-BE49-F238E27FC236}">
-                <a16:creationId xmlns:a16="http://schemas.microsoft.com/office/drawing/2014/main" id="{1011EF28-1D8A-4E7D-992F-FB57EF7CEB41}"/>
+                <a16:creationId xmlns:a16="http://schemas.microsoft.com/office/drawing/2014/main" id="{FD619C7A-31A3-46E6-B368-A6190EA74EAF}"/>
               </a:ext>
             </a:extLst>
           </p:cNvPr>
@@ -2902,7 +2902,7 @@
           <p:cNvPr id="5" name="Title-2-5">
             <a:extLst xmlns:a="http://schemas.openxmlformats.org/drawingml/2006/main">
               <a:ext uri="{FF2B5EF4-FFF2-40B4-BE49-F238E27FC236}">
-                <a16:creationId xmlns:a16="http://schemas.microsoft.com/office/drawing/2014/main" id="{DE3F60EC-F406-46AC-A8BE-36A5A146348D}"/>
+                <a16:creationId xmlns:a16="http://schemas.microsoft.com/office/drawing/2014/main" id="{530A4893-B0B7-408A-A527-723DDCA3125E}"/>
               </a:ext>
             </a:extLst>
           </p:cNvPr>
@@ -2947,7 +2947,7 @@
           <p:cNvPr id="6" name="Content-Placeholder-9-6">
             <a:extLst xmlns:a="http://schemas.openxmlformats.org/drawingml/2006/main">
               <a:ext uri="{FF2B5EF4-FFF2-40B4-BE49-F238E27FC236}">
-                <a16:creationId xmlns:a16="http://schemas.microsoft.com/office/drawing/2014/main" id="{A8074D8C-A2C5-43D4-BD83-97027AC340BC}"/>
+                <a16:creationId xmlns:a16="http://schemas.microsoft.com/office/drawing/2014/main" id="{E41AF180-8C7E-4940-8954-0661D233BCA2}"/>
               </a:ext>
             </a:extLst>
           </p:cNvPr>
@@ -2992,7 +2992,7 @@
           <p:cNvPr id="7" name="Content-Placeholder-10-7">
             <a:extLst xmlns:a="http://schemas.openxmlformats.org/drawingml/2006/main">
               <a:ext uri="{FF2B5EF4-FFF2-40B4-BE49-F238E27FC236}">
-                <a16:creationId xmlns:a16="http://schemas.microsoft.com/office/drawing/2014/main" id="{A9A61A39-1F99-41C9-875F-250A06336A22}"/>
+                <a16:creationId xmlns:a16="http://schemas.microsoft.com/office/drawing/2014/main" id="{1CC65187-ABBF-4626-B30B-248B43D2255A}"/>
               </a:ext>
             </a:extLst>
           </p:cNvPr>
@@ -3037,7 +3037,7 @@
           <p:cNvPr id="8" name="Content-Placeholder-11-8">
             <a:extLst xmlns:a="http://schemas.openxmlformats.org/drawingml/2006/main">
               <a:ext uri="{FF2B5EF4-FFF2-40B4-BE49-F238E27FC236}">
-                <a16:creationId xmlns:a16="http://schemas.microsoft.com/office/drawing/2014/main" id="{74C14F7A-C176-430E-A855-680C001CC227}"/>
+                <a16:creationId xmlns:a16="http://schemas.microsoft.com/office/drawing/2014/main" id="{CA133300-6C2B-4A02-A400-CC195C7D17D1}"/>
               </a:ext>
             </a:extLst>
           </p:cNvPr>
@@ -3082,7 +3082,7 @@
           <p:cNvPr id="9" name="Content-Placeholder-9-9">
             <a:extLst xmlns:a="http://schemas.openxmlformats.org/drawingml/2006/main">
               <a:ext uri="{FF2B5EF4-FFF2-40B4-BE49-F238E27FC236}">
-                <a16:creationId xmlns:a16="http://schemas.microsoft.com/office/drawing/2014/main" id="{99DF400A-E95A-45D0-AE26-7A7E184C9E80}"/>
+                <a16:creationId xmlns:a16="http://schemas.microsoft.com/office/drawing/2014/main" id="{6088A9B1-4B65-4C2B-A313-35CAA23148BF}"/>
               </a:ext>
             </a:extLst>
           </p:cNvPr>
@@ -3127,7 +3127,7 @@
           <p:cNvPr id="10" name="Content-Placeholder-9-10">
             <a:extLst xmlns:a="http://schemas.openxmlformats.org/drawingml/2006/main">
               <a:ext uri="{FF2B5EF4-FFF2-40B4-BE49-F238E27FC236}">
-                <a16:creationId xmlns:a16="http://schemas.microsoft.com/office/drawing/2014/main" id="{3883A39F-39D8-4AD9-92BE-F2EEEAE6DAAA}"/>
+                <a16:creationId xmlns:a16="http://schemas.microsoft.com/office/drawing/2014/main" id="{A053A5F7-BABA-4048-B652-9B24DEE754A5}"/>
               </a:ext>
             </a:extLst>
           </p:cNvPr>
@@ -3162,7 +3162,7 @@
               </a:defRPr>
             </a:pPr>
             <a:r>
-              <a:t>208</a:t>
+              <a:t>209</a:t>
             </a:r>
           </a:p>
         </p:txBody>
@@ -3172,7 +3172,7 @@
           <p:cNvPr id="11" name="Content-Placeholder-9-11">
             <a:extLst xmlns:a="http://schemas.openxmlformats.org/drawingml/2006/main">
               <a:ext uri="{FF2B5EF4-FFF2-40B4-BE49-F238E27FC236}">
-                <a16:creationId xmlns:a16="http://schemas.microsoft.com/office/drawing/2014/main" id="{F369EBDB-2B7B-4999-A1B6-979A8D56D8EE}"/>
+                <a16:creationId xmlns:a16="http://schemas.microsoft.com/office/drawing/2014/main" id="{14829EC8-4532-4FF2-B6C4-55A881F39130}"/>
               </a:ext>
             </a:extLst>
           </p:cNvPr>
@@ -3207,7 +3207,7 @@
               </a:defRPr>
             </a:pPr>
             <a:r>
-              <a:t>25/25</a:t>
+              <a:t>27/27</a:t>
             </a:r>
           </a:p>
         </p:txBody>
@@ -3217,7 +3217,7 @@
           <p:cNvPr id="12" name="Content-Placeholder-15-12">
             <a:extLst xmlns:a="http://schemas.openxmlformats.org/drawingml/2006/main">
               <a:ext uri="{FF2B5EF4-FFF2-40B4-BE49-F238E27FC236}">
-                <a16:creationId xmlns:a16="http://schemas.microsoft.com/office/drawing/2014/main" id="{B57908A2-E6C0-4E49-AB33-DE33498143A4}"/>
+                <a16:creationId xmlns:a16="http://schemas.microsoft.com/office/drawing/2014/main" id="{57E60B0C-A1DE-4613-A955-9311B22472E1}"/>
               </a:ext>
             </a:extLst>
           </p:cNvPr>
@@ -3275,7 +3275,7 @@
     </p:spTree>
     <p:extLst>
       <p:ext uri="{BB962C8B-B14F-4D97-AF65-F5344CB8AC3E}">
-        <p14:creationId xmlns:p14="http://schemas.microsoft.com/office/powerpoint/2010/main" val="1225048336"/>
+        <p14:creationId xmlns:p14="http://schemas.microsoft.com/office/powerpoint/2010/main" val="1772312935"/>
       </p:ext>
     </p:extLst>
   </p:cSld>
@@ -3299,7 +3299,7 @@
           <p:cNvPr id="10" name="Google-Shape-532-p58-2">
             <a:extLst xmlns:a="http://schemas.openxmlformats.org/drawingml/2006/main">
               <a:ext uri="{FF2B5EF4-FFF2-40B4-BE49-F238E27FC236}">
-                <a16:creationId xmlns:a16="http://schemas.microsoft.com/office/drawing/2014/main" id="{DF3171F4-251B-477B-8BE2-DD888E9B830A}"/>
+                <a16:creationId xmlns:a16="http://schemas.microsoft.com/office/drawing/2014/main" id="{F2C8A358-2CED-4AE1-8684-8D883A40284A}"/>
               </a:ext>
             </a:extLst>
           </p:cNvPr>
@@ -3344,7 +3344,7 @@
           <p:cNvPr id="2" name="Google-Shape-533-p58-3">
             <a:extLst xmlns:a="http://schemas.openxmlformats.org/drawingml/2006/main">
               <a:ext uri="{FF2B5EF4-FFF2-40B4-BE49-F238E27FC236}">
-                <a16:creationId xmlns:a16="http://schemas.microsoft.com/office/drawing/2014/main" id="{2BA3512C-3841-40B0-91C6-64B7E00FB9CF}"/>
+                <a16:creationId xmlns:a16="http://schemas.microsoft.com/office/drawing/2014/main" id="{1FA45B3A-DB30-4A2B-B6C5-41DA0C6B368A}"/>
               </a:ext>
             </a:extLst>
           </p:cNvPr>
@@ -3389,7 +3389,7 @@
           <p:cNvPr id="3" name="Rounded-Rectangle-1-4">
             <a:extLst xmlns:a="http://schemas.openxmlformats.org/drawingml/2006/main">
               <a:ext uri="{FF2B5EF4-FFF2-40B4-BE49-F238E27FC236}">
-                <a16:creationId xmlns:a16="http://schemas.microsoft.com/office/drawing/2014/main" id="{639CAD7B-6F00-43D9-9585-603704A06A38}"/>
+                <a16:creationId xmlns:a16="http://schemas.microsoft.com/office/drawing/2014/main" id="{8F1329E7-C6AC-4E25-9590-01B0AD366EAB}"/>
               </a:ext>
             </a:extLst>
           </p:cNvPr>
@@ -3418,7 +3418,7 @@
           <p:cNvPr id="4" name="Content-Placeholder-10-5">
             <a:extLst xmlns:a="http://schemas.openxmlformats.org/drawingml/2006/main">
               <a:ext uri="{FF2B5EF4-FFF2-40B4-BE49-F238E27FC236}">
-                <a16:creationId xmlns:a16="http://schemas.microsoft.com/office/drawing/2014/main" id="{6A7A4BBE-DE72-4AB6-B04B-6580CE34CE62}"/>
+                <a16:creationId xmlns:a16="http://schemas.microsoft.com/office/drawing/2014/main" id="{6B431540-3711-4565-841A-1A85C3DA0C66}"/>
               </a:ext>
             </a:extLst>
           </p:cNvPr>
@@ -3463,7 +3463,7 @@
           <p:cNvPr id="5" name="Content-Placeholder-15-6">
             <a:extLst xmlns:a="http://schemas.openxmlformats.org/drawingml/2006/main">
               <a:ext uri="{FF2B5EF4-FFF2-40B4-BE49-F238E27FC236}">
-                <a16:creationId xmlns:a16="http://schemas.microsoft.com/office/drawing/2014/main" id="{8A4E06D7-0550-4888-90AE-0F71207DB5C0}"/>
+                <a16:creationId xmlns:a16="http://schemas.microsoft.com/office/drawing/2014/main" id="{AC28460B-EAA4-4ECC-8BBD-CA190DB4249B}"/>
               </a:ext>
             </a:extLst>
           </p:cNvPr>
@@ -3538,7 +3538,7 @@
           <p:cNvPr id="6" name="Rounded-Rectangle-7-7">
             <a:extLst xmlns:a="http://schemas.openxmlformats.org/drawingml/2006/main">
               <a:ext uri="{FF2B5EF4-FFF2-40B4-BE49-F238E27FC236}">
-                <a16:creationId xmlns:a16="http://schemas.microsoft.com/office/drawing/2014/main" id="{5E896D4F-C06C-495F-A0A8-EA4B606E76C0}"/>
+                <a16:creationId xmlns:a16="http://schemas.microsoft.com/office/drawing/2014/main" id="{7ADAE043-91EA-4DCA-BEB4-77F32BD905FF}"/>
               </a:ext>
             </a:extLst>
           </p:cNvPr>
@@ -3567,7 +3567,7 @@
           <p:cNvPr id="7" name="Content-Placeholder-10-8">
             <a:extLst xmlns:a="http://schemas.openxmlformats.org/drawingml/2006/main">
               <a:ext uri="{FF2B5EF4-FFF2-40B4-BE49-F238E27FC236}">
-                <a16:creationId xmlns:a16="http://schemas.microsoft.com/office/drawing/2014/main" id="{9B5E9B62-93E5-46E2-8128-E80BAC796669}"/>
+                <a16:creationId xmlns:a16="http://schemas.microsoft.com/office/drawing/2014/main" id="{0572B6D3-A089-45DA-8D76-F056C392EEEE}"/>
               </a:ext>
             </a:extLst>
           </p:cNvPr>
@@ -3612,7 +3612,7 @@
           <p:cNvPr id="8" name="Content-Placeholder-15-9">
             <a:extLst xmlns:a="http://schemas.openxmlformats.org/drawingml/2006/main">
               <a:ext uri="{FF2B5EF4-FFF2-40B4-BE49-F238E27FC236}">
-                <a16:creationId xmlns:a16="http://schemas.microsoft.com/office/drawing/2014/main" id="{AF3D0C67-8AB2-4163-95D9-CEBEC3907781}"/>
+                <a16:creationId xmlns:a16="http://schemas.microsoft.com/office/drawing/2014/main" id="{23E01ADB-5963-48F0-A89F-39AF05283A56}"/>
               </a:ext>
             </a:extLst>
           </p:cNvPr>
@@ -3687,7 +3687,7 @@
           <p:cNvPr id="9" name="Content-Placeholder-15-10">
             <a:extLst xmlns:a="http://schemas.openxmlformats.org/drawingml/2006/main">
               <a:ext uri="{FF2B5EF4-FFF2-40B4-BE49-F238E27FC236}">
-                <a16:creationId xmlns:a16="http://schemas.microsoft.com/office/drawing/2014/main" id="{AFD506DD-81E2-4175-9E65-C8B926078BED}"/>
+                <a16:creationId xmlns:a16="http://schemas.microsoft.com/office/drawing/2014/main" id="{BC2F58A0-5A8F-4601-9A90-4B66AF3C1AFB}"/>
               </a:ext>
             </a:extLst>
           </p:cNvPr>
@@ -3760,7 +3760,7 @@
     </p:spTree>
     <p:extLst>
       <p:ext uri="{BB962C8B-B14F-4D97-AF65-F5344CB8AC3E}">
-        <p14:creationId xmlns:p14="http://schemas.microsoft.com/office/powerpoint/2010/main" val="9047412"/>
+        <p14:creationId xmlns:p14="http://schemas.microsoft.com/office/powerpoint/2010/main" val="2057769865"/>
       </p:ext>
     </p:extLst>
   </p:cSld>
@@ -3784,7 +3784,7 @@
           <p:cNvPr id="13" name="Slide-Number-Placeholder-3-2">
             <a:extLst xmlns:a="http://schemas.openxmlformats.org/drawingml/2006/main">
               <a:ext uri="{FF2B5EF4-FFF2-40B4-BE49-F238E27FC236}">
-                <a16:creationId xmlns:a16="http://schemas.microsoft.com/office/drawing/2014/main" id="{BB0021EC-2996-48FA-9BB0-64B483D0BB6C}"/>
+                <a16:creationId xmlns:a16="http://schemas.microsoft.com/office/drawing/2014/main" id="{CE15B07C-A88B-44FF-8EC5-CF07E230DD19}"/>
               </a:ext>
             </a:extLst>
           </p:cNvPr>
@@ -3827,7 +3827,7 @@
           <p:cNvPr id="2" name="Title-10-3">
             <a:extLst xmlns:a="http://schemas.openxmlformats.org/drawingml/2006/main">
               <a:ext uri="{FF2B5EF4-FFF2-40B4-BE49-F238E27FC236}">
-                <a16:creationId xmlns:a16="http://schemas.microsoft.com/office/drawing/2014/main" id="{5E97ED50-5103-485A-B5D1-02AA60698766}"/>
+                <a16:creationId xmlns:a16="http://schemas.microsoft.com/office/drawing/2014/main" id="{CD6EEB58-7C90-41E6-8B50-AECA761C8B0F}"/>
               </a:ext>
             </a:extLst>
           </p:cNvPr>
@@ -3894,7 +3894,7 @@
           <p:cNvPr id="4" name="Google-Shape-2260-p159-5">
             <a:extLst xmlns:a="http://schemas.openxmlformats.org/drawingml/2006/main">
               <a:ext uri="{FF2B5EF4-FFF2-40B4-BE49-F238E27FC236}">
-                <a16:creationId xmlns:a16="http://schemas.microsoft.com/office/drawing/2014/main" id="{41ADAF13-B214-4EBF-A203-3742D0565111}"/>
+                <a16:creationId xmlns:a16="http://schemas.microsoft.com/office/drawing/2014/main" id="{55F5B78B-2FA7-4BA0-B019-D42B718A3F02}"/>
               </a:ext>
             </a:extLst>
           </p:cNvPr>
@@ -3921,7 +3921,7 @@
           <p:cNvPr id="5" name="Google-Shape-2261-p159-6">
             <a:extLst xmlns:a="http://schemas.openxmlformats.org/drawingml/2006/main">
               <a:ext uri="{FF2B5EF4-FFF2-40B4-BE49-F238E27FC236}">
-                <a16:creationId xmlns:a16="http://schemas.microsoft.com/office/drawing/2014/main" id="{1F22A56E-339D-483F-9F56-018C30629A44}"/>
+                <a16:creationId xmlns:a16="http://schemas.microsoft.com/office/drawing/2014/main" id="{B8BE3E32-7A79-482B-B596-998738A724BB}"/>
               </a:ext>
             </a:extLst>
           </p:cNvPr>
@@ -3948,7 +3948,7 @@
           <p:cNvPr id="6" name="Google-Shape-2262-p159-7">
             <a:extLst xmlns:a="http://schemas.openxmlformats.org/drawingml/2006/main">
               <a:ext uri="{FF2B5EF4-FFF2-40B4-BE49-F238E27FC236}">
-                <a16:creationId xmlns:a16="http://schemas.microsoft.com/office/drawing/2014/main" id="{2F687AA9-E157-4B7D-8078-9587AFB8E536}"/>
+                <a16:creationId xmlns:a16="http://schemas.microsoft.com/office/drawing/2014/main" id="{DD3C2C90-8B3E-4353-B393-D7CE0A1AD7BB}"/>
               </a:ext>
             </a:extLst>
           </p:cNvPr>
@@ -3975,7 +3975,7 @@
           <p:cNvPr id="7" name="Content-Placeholder-15-8">
             <a:extLst xmlns:a="http://schemas.openxmlformats.org/drawingml/2006/main">
               <a:ext uri="{FF2B5EF4-FFF2-40B4-BE49-F238E27FC236}">
-                <a16:creationId xmlns:a16="http://schemas.microsoft.com/office/drawing/2014/main" id="{4E1CD546-9023-43D6-95EC-53D83B7D6304}"/>
+                <a16:creationId xmlns:a16="http://schemas.microsoft.com/office/drawing/2014/main" id="{6DBF4FB0-5B1E-4D2E-ADAE-D81810948222}"/>
               </a:ext>
             </a:extLst>
           </p:cNvPr>
@@ -4020,7 +4020,7 @@
           <p:cNvPr id="8" name="Content-Placeholder-15-9">
             <a:extLst xmlns:a="http://schemas.openxmlformats.org/drawingml/2006/main">
               <a:ext uri="{FF2B5EF4-FFF2-40B4-BE49-F238E27FC236}">
-                <a16:creationId xmlns:a16="http://schemas.microsoft.com/office/drawing/2014/main" id="{FFD249A7-2BC0-43DA-8379-D634A3DBA50A}"/>
+                <a16:creationId xmlns:a16="http://schemas.microsoft.com/office/drawing/2014/main" id="{FA5916C5-263D-4BB8-9BC4-476076B7B5C8}"/>
               </a:ext>
             </a:extLst>
           </p:cNvPr>
@@ -4065,7 +4065,7 @@
           <p:cNvPr id="9" name="Content-Placeholder-15-10">
             <a:extLst xmlns:a="http://schemas.openxmlformats.org/drawingml/2006/main">
               <a:ext uri="{FF2B5EF4-FFF2-40B4-BE49-F238E27FC236}">
-                <a16:creationId xmlns:a16="http://schemas.microsoft.com/office/drawing/2014/main" id="{11DF7A7C-5DCD-4672-A7C7-B59E394B0232}"/>
+                <a16:creationId xmlns:a16="http://schemas.microsoft.com/office/drawing/2014/main" id="{B382BC17-3440-4261-8A1B-5257C4317E56}"/>
               </a:ext>
             </a:extLst>
           </p:cNvPr>
@@ -4110,7 +4110,7 @@
           <p:cNvPr id="10" name="Text-Placeholder-16-11">
             <a:extLst xmlns:a="http://schemas.openxmlformats.org/drawingml/2006/main">
               <a:ext uri="{FF2B5EF4-FFF2-40B4-BE49-F238E27FC236}">
-                <a16:creationId xmlns:a16="http://schemas.microsoft.com/office/drawing/2014/main" id="{6B6E311E-254B-4D72-A73E-B5887B9BC208}"/>
+                <a16:creationId xmlns:a16="http://schemas.microsoft.com/office/drawing/2014/main" id="{72BB1B6E-24CE-4880-91FF-7A6D55DC6A7B}"/>
               </a:ext>
             </a:extLst>
           </p:cNvPr>
@@ -4170,7 +4170,7 @@
           <p:cNvPr id="11" name="Text-Placeholder-16-12">
             <a:extLst xmlns:a="http://schemas.openxmlformats.org/drawingml/2006/main">
               <a:ext uri="{FF2B5EF4-FFF2-40B4-BE49-F238E27FC236}">
-                <a16:creationId xmlns:a16="http://schemas.microsoft.com/office/drawing/2014/main" id="{FB74FAF6-CBE8-413B-AB6B-EC57B581D4DC}"/>
+                <a16:creationId xmlns:a16="http://schemas.microsoft.com/office/drawing/2014/main" id="{D3620E7B-D830-4FE9-A4B6-8604AAB3032B}"/>
               </a:ext>
             </a:extLst>
           </p:cNvPr>
@@ -4230,7 +4230,7 @@
           <p:cNvPr id="12" name="Text-Placeholder-16-13">
             <a:extLst xmlns:a="http://schemas.openxmlformats.org/drawingml/2006/main">
               <a:ext uri="{FF2B5EF4-FFF2-40B4-BE49-F238E27FC236}">
-                <a16:creationId xmlns:a16="http://schemas.microsoft.com/office/drawing/2014/main" id="{2EE73BCF-EE03-478C-B3C1-818CC037D90B}"/>
+                <a16:creationId xmlns:a16="http://schemas.microsoft.com/office/drawing/2014/main" id="{0DFDAAF0-D027-421C-A6CE-3F1740249E7D}"/>
               </a:ext>
             </a:extLst>
           </p:cNvPr>
@@ -4288,7 +4288,7 @@
     </p:spTree>
     <p:extLst>
       <p:ext uri="{BB962C8B-B14F-4D97-AF65-F5344CB8AC3E}">
-        <p14:creationId xmlns:p14="http://schemas.microsoft.com/office/powerpoint/2010/main" val="1686553945"/>
+        <p14:creationId xmlns:p14="http://schemas.microsoft.com/office/powerpoint/2010/main" val="1349016710"/>
       </p:ext>
     </p:extLst>
   </p:cSld>

</xml_diff>

<commit_message>
fix: preserve clarification context for RAG queries
</commit_message>
<xml_diff>
--- a/codebase/reference/demo-slides-source.pptx
+++ b/codebase/reference/demo-slides-source.pptx
@@ -2,18 +2,18 @@
 <file path=ppt/presentation.xml><?xml version="1.0" encoding="utf-8"?>
 <p:presentation xmlns:p="http://schemas.openxmlformats.org/presentationml/2006/main">
   <p:sldMasterIdLst>
-    <p:sldMasterId xmlns:r="http://schemas.openxmlformats.org/officeDocument/2006/relationships" id="2147483648" r:id="Rb81aef688d1740c6"/>
+    <p:sldMasterId xmlns:r="http://schemas.openxmlformats.org/officeDocument/2006/relationships" id="2147483648" r:id="R2a26a03fd0de4924"/>
   </p:sldMasterIdLst>
   <p:notesMasterIdLst>
-    <p:notesMasterId xmlns:r="http://schemas.openxmlformats.org/officeDocument/2006/relationships" r:id="R772b8c607efb4b91"/>
+    <p:notesMasterId xmlns:r="http://schemas.openxmlformats.org/officeDocument/2006/relationships" r:id="R6a0c0f15add7402f"/>
   </p:notesMasterIdLst>
   <p:sldIdLst>
-    <p:sldId xmlns:r="http://schemas.openxmlformats.org/officeDocument/2006/relationships" id="256" r:id="R463fe210f88a4920"/>
-    <p:sldId xmlns:r="http://schemas.openxmlformats.org/officeDocument/2006/relationships" id="257" r:id="R7f9fb2fdbd9541e9"/>
-    <p:sldId xmlns:r="http://schemas.openxmlformats.org/officeDocument/2006/relationships" id="258" r:id="Rc46ca8c540164075"/>
-    <p:sldId xmlns:r="http://schemas.openxmlformats.org/officeDocument/2006/relationships" id="259" r:id="Rb5d4c8f984194837"/>
-    <p:sldId xmlns:r="http://schemas.openxmlformats.org/officeDocument/2006/relationships" id="260" r:id="R30b93dfa98074e43"/>
-    <p:sldId xmlns:r="http://schemas.openxmlformats.org/officeDocument/2006/relationships" id="261" r:id="R1da1a553bc6942f5"/>
+    <p:sldId xmlns:r="http://schemas.openxmlformats.org/officeDocument/2006/relationships" id="256" r:id="R015a74f138a64129"/>
+    <p:sldId xmlns:r="http://schemas.openxmlformats.org/officeDocument/2006/relationships" id="257" r:id="R0504394a6f124694"/>
+    <p:sldId xmlns:r="http://schemas.openxmlformats.org/officeDocument/2006/relationships" id="258" r:id="R3a41df32dc144d19"/>
+    <p:sldId xmlns:r="http://schemas.openxmlformats.org/officeDocument/2006/relationships" id="259" r:id="R07494b8e7a004e55"/>
+    <p:sldId xmlns:r="http://schemas.openxmlformats.org/officeDocument/2006/relationships" id="260" r:id="R86339a02957e4586"/>
+    <p:sldId xmlns:r="http://schemas.openxmlformats.org/officeDocument/2006/relationships" id="261" r:id="Raea9d497571a4227"/>
   </p:sldIdLst>
   <p:sldSz cx="12192000" cy="6858000"/>
   <p:notesSz cx="6858000" cy="9144000"/>
@@ -1015,7 +1015,7 @@
   </p:cSld>
   <p:clrMap bg1="lt1" tx1="dk1" bg2="lt2" tx2="dk2" accent1="accent1" accent2="accent2" accent3="accent3" accent4="accent4" accent5="accent5" accent6="accent6" hlink="hlink" folHlink="folHlink"/>
   <p:sldLayoutIdLst>
-    <p:sldLayoutId xmlns:r="http://schemas.openxmlformats.org/officeDocument/2006/relationships" id="2147483649" r:id="R3260721015f14c51"/>
+    <p:sldLayoutId xmlns:r="http://schemas.openxmlformats.org/officeDocument/2006/relationships" id="2147483649" r:id="R2575e1cddfd64bd9"/>
   </p:sldLayoutIdLst>
   <p:txStyles>
     <p:titleStyle>
@@ -1559,7 +1559,7 @@
           <p:cNvPr id="4" name="Title-3-1">
             <a:extLst xmlns:a="http://schemas.openxmlformats.org/drawingml/2006/main">
               <a:ext uri="{FF2B5EF4-FFF2-40B4-BE49-F238E27FC236}">
-                <a16:creationId xmlns:a16="http://schemas.microsoft.com/office/drawing/2014/main" id="{774807FB-168A-4A05-B6F1-CA01087F3492}"/>
+                <a16:creationId xmlns:a16="http://schemas.microsoft.com/office/drawing/2014/main" id="{51C4FC16-F508-49F9-ADFC-23321E972DAC}"/>
               </a:ext>
             </a:extLst>
           </p:cNvPr>
@@ -1605,7 +1605,7 @@
           <p:cNvPr id="2" name="Subtitle-4-2">
             <a:extLst xmlns:a="http://schemas.openxmlformats.org/drawingml/2006/main">
               <a:ext uri="{FF2B5EF4-FFF2-40B4-BE49-F238E27FC236}">
-                <a16:creationId xmlns:a16="http://schemas.microsoft.com/office/drawing/2014/main" id="{373F6C4F-BCCC-4876-84FB-CE9C2E38DABC}"/>
+                <a16:creationId xmlns:a16="http://schemas.microsoft.com/office/drawing/2014/main" id="{48744603-CF39-442A-9F1E-3F3C07C5D4ED}"/>
               </a:ext>
             </a:extLst>
           </p:cNvPr>
@@ -1650,7 +1650,7 @@
           <p:cNvPr id="3" name="Subtitle-4-3">
             <a:extLst xmlns:a="http://schemas.openxmlformats.org/drawingml/2006/main">
               <a:ext uri="{FF2B5EF4-FFF2-40B4-BE49-F238E27FC236}">
-                <a16:creationId xmlns:a16="http://schemas.microsoft.com/office/drawing/2014/main" id="{6E635359-78B2-4B76-9674-CB82DDC5BDF3}"/>
+                <a16:creationId xmlns:a16="http://schemas.microsoft.com/office/drawing/2014/main" id="{5ECFC398-1E02-4F74-B224-0985EE295B25}"/>
               </a:ext>
             </a:extLst>
           </p:cNvPr>
@@ -1693,7 +1693,7 @@
     </p:spTree>
     <p:extLst>
       <p:ext uri="{BB962C8B-B14F-4D97-AF65-F5344CB8AC3E}">
-        <p14:creationId xmlns:p14="http://schemas.microsoft.com/office/powerpoint/2010/main" val="904841640"/>
+        <p14:creationId xmlns:p14="http://schemas.microsoft.com/office/powerpoint/2010/main" val="824251986"/>
       </p:ext>
     </p:extLst>
   </p:cSld>
@@ -1717,7 +1717,7 @@
           <p:cNvPr id="13" name="Rounded-Rectangle-5-1">
             <a:extLst xmlns:a="http://schemas.openxmlformats.org/drawingml/2006/main">
               <a:ext uri="{FF2B5EF4-FFF2-40B4-BE49-F238E27FC236}">
-                <a16:creationId xmlns:a16="http://schemas.microsoft.com/office/drawing/2014/main" id="{3005741E-D7E4-4420-8582-2350DA28F212}"/>
+                <a16:creationId xmlns:a16="http://schemas.microsoft.com/office/drawing/2014/main" id="{7ABC7B0C-5723-4FFF-80FF-A5CF6FD78019}"/>
               </a:ext>
             </a:extLst>
           </p:cNvPr>
@@ -1746,7 +1746,7 @@
           <p:cNvPr id="2" name="Rounded-Rectangle-6-2">
             <a:extLst xmlns:a="http://schemas.openxmlformats.org/drawingml/2006/main">
               <a:ext uri="{FF2B5EF4-FFF2-40B4-BE49-F238E27FC236}">
-                <a16:creationId xmlns:a16="http://schemas.microsoft.com/office/drawing/2014/main" id="{150F0691-C415-43D1-A8B2-9387ABEB3CE1}"/>
+                <a16:creationId xmlns:a16="http://schemas.microsoft.com/office/drawing/2014/main" id="{744088BE-23A2-4A32-A756-747945D10C09}"/>
               </a:ext>
             </a:extLst>
           </p:cNvPr>
@@ -1775,7 +1775,7 @@
           <p:cNvPr id="3" name="Rounded-Rectangle-7-3">
             <a:extLst xmlns:a="http://schemas.openxmlformats.org/drawingml/2006/main">
               <a:ext uri="{FF2B5EF4-FFF2-40B4-BE49-F238E27FC236}">
-                <a16:creationId xmlns:a16="http://schemas.microsoft.com/office/drawing/2014/main" id="{66B7A448-1FBB-4343-B88B-7D1201F11FEF}"/>
+                <a16:creationId xmlns:a16="http://schemas.microsoft.com/office/drawing/2014/main" id="{9CF1920E-5F88-4D6C-BD27-3F58BCF1FA78}"/>
               </a:ext>
             </a:extLst>
           </p:cNvPr>
@@ -1804,7 +1804,7 @@
           <p:cNvPr id="4" name="Slide-Number-Placeholder-1-4">
             <a:extLst xmlns:a="http://schemas.openxmlformats.org/drawingml/2006/main">
               <a:ext uri="{FF2B5EF4-FFF2-40B4-BE49-F238E27FC236}">
-                <a16:creationId xmlns:a16="http://schemas.microsoft.com/office/drawing/2014/main" id="{163F1A54-166E-41CD-8F44-9A7E78BAA5B6}"/>
+                <a16:creationId xmlns:a16="http://schemas.microsoft.com/office/drawing/2014/main" id="{15F62FE2-5068-4D5A-8777-02FAED4D7056}"/>
               </a:ext>
             </a:extLst>
           </p:cNvPr>
@@ -1847,7 +1847,7 @@
           <p:cNvPr id="5" name="Title-2-5">
             <a:extLst xmlns:a="http://schemas.openxmlformats.org/drawingml/2006/main">
               <a:ext uri="{FF2B5EF4-FFF2-40B4-BE49-F238E27FC236}">
-                <a16:creationId xmlns:a16="http://schemas.microsoft.com/office/drawing/2014/main" id="{76F8127F-57E8-44CE-8CD3-D52CFA5F5F02}"/>
+                <a16:creationId xmlns:a16="http://schemas.microsoft.com/office/drawing/2014/main" id="{C82C7B2F-6683-42F7-816F-5159A067D3D8}"/>
               </a:ext>
             </a:extLst>
           </p:cNvPr>
@@ -1892,7 +1892,7 @@
           <p:cNvPr id="6" name="Content-Placeholder-9-6">
             <a:extLst xmlns:a="http://schemas.openxmlformats.org/drawingml/2006/main">
               <a:ext uri="{FF2B5EF4-FFF2-40B4-BE49-F238E27FC236}">
-                <a16:creationId xmlns:a16="http://schemas.microsoft.com/office/drawing/2014/main" id="{7E161122-2A90-491B-AF69-A54099AED875}"/>
+                <a16:creationId xmlns:a16="http://schemas.microsoft.com/office/drawing/2014/main" id="{F39094E5-FBA1-4EE5-8C5B-18FDFC1409FE}"/>
               </a:ext>
             </a:extLst>
           </p:cNvPr>
@@ -1937,7 +1937,7 @@
           <p:cNvPr id="7" name="Content-Placeholder-10-7">
             <a:extLst xmlns:a="http://schemas.openxmlformats.org/drawingml/2006/main">
               <a:ext uri="{FF2B5EF4-FFF2-40B4-BE49-F238E27FC236}">
-                <a16:creationId xmlns:a16="http://schemas.microsoft.com/office/drawing/2014/main" id="{6E3A7459-50DE-4720-961A-4FE461EFACCB}"/>
+                <a16:creationId xmlns:a16="http://schemas.microsoft.com/office/drawing/2014/main" id="{BC7ACC9B-C841-4907-ACEC-E6CD86766EB0}"/>
               </a:ext>
             </a:extLst>
           </p:cNvPr>
@@ -1982,7 +1982,7 @@
           <p:cNvPr id="8" name="Content-Placeholder-11-8">
             <a:extLst xmlns:a="http://schemas.openxmlformats.org/drawingml/2006/main">
               <a:ext uri="{FF2B5EF4-FFF2-40B4-BE49-F238E27FC236}">
-                <a16:creationId xmlns:a16="http://schemas.microsoft.com/office/drawing/2014/main" id="{CFC2823E-24EC-4D7C-9B6D-864B470FBA08}"/>
+                <a16:creationId xmlns:a16="http://schemas.microsoft.com/office/drawing/2014/main" id="{6F16BF80-5460-4C53-B077-5105C984A05F}"/>
               </a:ext>
             </a:extLst>
           </p:cNvPr>
@@ -2027,7 +2027,7 @@
           <p:cNvPr id="9" name="Content-Placeholder-9-9">
             <a:extLst xmlns:a="http://schemas.openxmlformats.org/drawingml/2006/main">
               <a:ext uri="{FF2B5EF4-FFF2-40B4-BE49-F238E27FC236}">
-                <a16:creationId xmlns:a16="http://schemas.microsoft.com/office/drawing/2014/main" id="{8776C1D6-A7CB-4559-99BA-6428ABFACDB3}"/>
+                <a16:creationId xmlns:a16="http://schemas.microsoft.com/office/drawing/2014/main" id="{35436D22-4AC3-48C2-8A5D-5B934867E722}"/>
               </a:ext>
             </a:extLst>
           </p:cNvPr>
@@ -2072,7 +2072,7 @@
           <p:cNvPr id="10" name="Content-Placeholder-9-10">
             <a:extLst xmlns:a="http://schemas.openxmlformats.org/drawingml/2006/main">
               <a:ext uri="{FF2B5EF4-FFF2-40B4-BE49-F238E27FC236}">
-                <a16:creationId xmlns:a16="http://schemas.microsoft.com/office/drawing/2014/main" id="{B67008F3-B0A9-4B3C-8A07-58362509A3F6}"/>
+                <a16:creationId xmlns:a16="http://schemas.microsoft.com/office/drawing/2014/main" id="{84CDBF85-579B-419C-BD83-1E8F680EE0F1}"/>
               </a:ext>
             </a:extLst>
           </p:cNvPr>
@@ -2117,7 +2117,7 @@
           <p:cNvPr id="11" name="Content-Placeholder-9-11">
             <a:extLst xmlns:a="http://schemas.openxmlformats.org/drawingml/2006/main">
               <a:ext uri="{FF2B5EF4-FFF2-40B4-BE49-F238E27FC236}">
-                <a16:creationId xmlns:a16="http://schemas.microsoft.com/office/drawing/2014/main" id="{7E384708-D929-4D9E-B18C-E9082890364C}"/>
+                <a16:creationId xmlns:a16="http://schemas.microsoft.com/office/drawing/2014/main" id="{9D02B714-4420-4988-8036-9E711C5709DA}"/>
               </a:ext>
             </a:extLst>
           </p:cNvPr>
@@ -2162,7 +2162,7 @@
           <p:cNvPr id="12" name="Content-Placeholder-15-12">
             <a:extLst xmlns:a="http://schemas.openxmlformats.org/drawingml/2006/main">
               <a:ext uri="{FF2B5EF4-FFF2-40B4-BE49-F238E27FC236}">
-                <a16:creationId xmlns:a16="http://schemas.microsoft.com/office/drawing/2014/main" id="{EFEC39B8-0B25-420F-8633-5B60E119BFFF}"/>
+                <a16:creationId xmlns:a16="http://schemas.microsoft.com/office/drawing/2014/main" id="{85B3A566-742A-4881-891F-AF60BFFAE23A}"/>
               </a:ext>
             </a:extLst>
           </p:cNvPr>
@@ -2220,7 +2220,7 @@
     </p:spTree>
     <p:extLst>
       <p:ext uri="{BB962C8B-B14F-4D97-AF65-F5344CB8AC3E}">
-        <p14:creationId xmlns:p14="http://schemas.microsoft.com/office/powerpoint/2010/main" val="197517484"/>
+        <p14:creationId xmlns:p14="http://schemas.microsoft.com/office/powerpoint/2010/main" val="535541686"/>
       </p:ext>
     </p:extLst>
   </p:cSld>
@@ -2244,7 +2244,7 @@
           <p:cNvPr id="13" name="Slide-Number-Placeholder-3-2">
             <a:extLst xmlns:a="http://schemas.openxmlformats.org/drawingml/2006/main">
               <a:ext uri="{FF2B5EF4-FFF2-40B4-BE49-F238E27FC236}">
-                <a16:creationId xmlns:a16="http://schemas.microsoft.com/office/drawing/2014/main" id="{343C01DC-E4B3-47C5-B329-041EDA541BA0}"/>
+                <a16:creationId xmlns:a16="http://schemas.microsoft.com/office/drawing/2014/main" id="{8D7EB9F7-F7DC-4D13-9FDD-2DF17C9418A8}"/>
               </a:ext>
             </a:extLst>
           </p:cNvPr>
@@ -2287,7 +2287,7 @@
           <p:cNvPr id="2" name="Title-10-3">
             <a:extLst xmlns:a="http://schemas.openxmlformats.org/drawingml/2006/main">
               <a:ext uri="{FF2B5EF4-FFF2-40B4-BE49-F238E27FC236}">
-                <a16:creationId xmlns:a16="http://schemas.microsoft.com/office/drawing/2014/main" id="{F4125E8E-B3BF-41B8-BA9D-5BAD3EE5F4D3}"/>
+                <a16:creationId xmlns:a16="http://schemas.microsoft.com/office/drawing/2014/main" id="{E26FBA23-F887-4351-B53B-18A3A250C07F}"/>
               </a:ext>
             </a:extLst>
           </p:cNvPr>
@@ -2354,7 +2354,7 @@
           <p:cNvPr id="4" name="Google-Shape-2260-p159-5">
             <a:extLst xmlns:a="http://schemas.openxmlformats.org/drawingml/2006/main">
               <a:ext uri="{FF2B5EF4-FFF2-40B4-BE49-F238E27FC236}">
-                <a16:creationId xmlns:a16="http://schemas.microsoft.com/office/drawing/2014/main" id="{0DEF28A8-3D16-4282-9D2C-7AF222245892}"/>
+                <a16:creationId xmlns:a16="http://schemas.microsoft.com/office/drawing/2014/main" id="{CD8C0710-5DFA-4F80-8D96-1EE7385E99F5}"/>
               </a:ext>
             </a:extLst>
           </p:cNvPr>
@@ -2381,7 +2381,7 @@
           <p:cNvPr id="5" name="Google-Shape-2261-p159-6">
             <a:extLst xmlns:a="http://schemas.openxmlformats.org/drawingml/2006/main">
               <a:ext uri="{FF2B5EF4-FFF2-40B4-BE49-F238E27FC236}">
-                <a16:creationId xmlns:a16="http://schemas.microsoft.com/office/drawing/2014/main" id="{D54BAF61-15F4-4FEB-B864-92B00D96E66A}"/>
+                <a16:creationId xmlns:a16="http://schemas.microsoft.com/office/drawing/2014/main" id="{2F5C9608-5AC0-4C54-9C8F-C6465089FD70}"/>
               </a:ext>
             </a:extLst>
           </p:cNvPr>
@@ -2408,7 +2408,7 @@
           <p:cNvPr id="6" name="Google-Shape-2262-p159-7">
             <a:extLst xmlns:a="http://schemas.openxmlformats.org/drawingml/2006/main">
               <a:ext uri="{FF2B5EF4-FFF2-40B4-BE49-F238E27FC236}">
-                <a16:creationId xmlns:a16="http://schemas.microsoft.com/office/drawing/2014/main" id="{5C3144BD-AB47-4B54-9437-4A17509EFE02}"/>
+                <a16:creationId xmlns:a16="http://schemas.microsoft.com/office/drawing/2014/main" id="{F2202D69-2425-4D69-9038-17E4DD07D8FA}"/>
               </a:ext>
             </a:extLst>
           </p:cNvPr>
@@ -2435,7 +2435,7 @@
           <p:cNvPr id="7" name="Content-Placeholder-15-8">
             <a:extLst xmlns:a="http://schemas.openxmlformats.org/drawingml/2006/main">
               <a:ext uri="{FF2B5EF4-FFF2-40B4-BE49-F238E27FC236}">
-                <a16:creationId xmlns:a16="http://schemas.microsoft.com/office/drawing/2014/main" id="{3930CF47-91C0-4717-B553-54AF2B9E8F07}"/>
+                <a16:creationId xmlns:a16="http://schemas.microsoft.com/office/drawing/2014/main" id="{5A3D57B1-0409-43B8-90C7-3DA05EF2D99C}"/>
               </a:ext>
             </a:extLst>
           </p:cNvPr>
@@ -2480,7 +2480,7 @@
           <p:cNvPr id="8" name="Content-Placeholder-15-9">
             <a:extLst xmlns:a="http://schemas.openxmlformats.org/drawingml/2006/main">
               <a:ext uri="{FF2B5EF4-FFF2-40B4-BE49-F238E27FC236}">
-                <a16:creationId xmlns:a16="http://schemas.microsoft.com/office/drawing/2014/main" id="{2EBF980C-A676-49DC-9A50-AAB5C2AA2E83}"/>
+                <a16:creationId xmlns:a16="http://schemas.microsoft.com/office/drawing/2014/main" id="{AE779255-7A5A-4DBC-A3AB-B37C3506F0C6}"/>
               </a:ext>
             </a:extLst>
           </p:cNvPr>
@@ -2525,7 +2525,7 @@
           <p:cNvPr id="9" name="Content-Placeholder-15-10">
             <a:extLst xmlns:a="http://schemas.openxmlformats.org/drawingml/2006/main">
               <a:ext uri="{FF2B5EF4-FFF2-40B4-BE49-F238E27FC236}">
-                <a16:creationId xmlns:a16="http://schemas.microsoft.com/office/drawing/2014/main" id="{8728A4B6-4005-4BAF-B873-11E56559E73A}"/>
+                <a16:creationId xmlns:a16="http://schemas.microsoft.com/office/drawing/2014/main" id="{C353C066-7CC5-40AF-9E12-BF4EBA0EFE4B}"/>
               </a:ext>
             </a:extLst>
           </p:cNvPr>
@@ -2570,7 +2570,7 @@
           <p:cNvPr id="10" name="Text-Placeholder-16-11">
             <a:extLst xmlns:a="http://schemas.openxmlformats.org/drawingml/2006/main">
               <a:ext uri="{FF2B5EF4-FFF2-40B4-BE49-F238E27FC236}">
-                <a16:creationId xmlns:a16="http://schemas.microsoft.com/office/drawing/2014/main" id="{941AA2CA-547E-4D2E-AD52-749A5025D520}"/>
+                <a16:creationId xmlns:a16="http://schemas.microsoft.com/office/drawing/2014/main" id="{946AA559-8521-4D52-85E4-23EB1299E8FC}"/>
               </a:ext>
             </a:extLst>
           </p:cNvPr>
@@ -2630,7 +2630,7 @@
           <p:cNvPr id="11" name="Text-Placeholder-16-12">
             <a:extLst xmlns:a="http://schemas.openxmlformats.org/drawingml/2006/main">
               <a:ext uri="{FF2B5EF4-FFF2-40B4-BE49-F238E27FC236}">
-                <a16:creationId xmlns:a16="http://schemas.microsoft.com/office/drawing/2014/main" id="{2B71D42C-556A-4D59-9917-E67F95976AC8}"/>
+                <a16:creationId xmlns:a16="http://schemas.microsoft.com/office/drawing/2014/main" id="{261B14DD-40BD-4296-BA36-D43AC4CDB704}"/>
               </a:ext>
             </a:extLst>
           </p:cNvPr>
@@ -2690,7 +2690,7 @@
           <p:cNvPr id="12" name="Text-Placeholder-16-13">
             <a:extLst xmlns:a="http://schemas.openxmlformats.org/drawingml/2006/main">
               <a:ext uri="{FF2B5EF4-FFF2-40B4-BE49-F238E27FC236}">
-                <a16:creationId xmlns:a16="http://schemas.microsoft.com/office/drawing/2014/main" id="{3BA42B70-462A-499F-A3F2-1825DFCAB93E}"/>
+                <a16:creationId xmlns:a16="http://schemas.microsoft.com/office/drawing/2014/main" id="{55E9702A-40D3-4D83-AB90-623BD419BFDB}"/>
               </a:ext>
             </a:extLst>
           </p:cNvPr>
@@ -2748,7 +2748,7 @@
     </p:spTree>
     <p:extLst>
       <p:ext uri="{BB962C8B-B14F-4D97-AF65-F5344CB8AC3E}">
-        <p14:creationId xmlns:p14="http://schemas.microsoft.com/office/powerpoint/2010/main" val="1449201615"/>
+        <p14:creationId xmlns:p14="http://schemas.microsoft.com/office/powerpoint/2010/main" val="830349375"/>
       </p:ext>
     </p:extLst>
   </p:cSld>
@@ -2772,7 +2772,7 @@
           <p:cNvPr id="13" name="Rounded-Rectangle-5-1">
             <a:extLst xmlns:a="http://schemas.openxmlformats.org/drawingml/2006/main">
               <a:ext uri="{FF2B5EF4-FFF2-40B4-BE49-F238E27FC236}">
-                <a16:creationId xmlns:a16="http://schemas.microsoft.com/office/drawing/2014/main" id="{AB256EB1-5F3F-4BD5-BF42-F4428F7C27E4}"/>
+                <a16:creationId xmlns:a16="http://schemas.microsoft.com/office/drawing/2014/main" id="{05160DCC-307F-41A7-9871-3A4C10FA952C}"/>
               </a:ext>
             </a:extLst>
           </p:cNvPr>
@@ -2801,7 +2801,7 @@
           <p:cNvPr id="2" name="Rounded-Rectangle-6-2">
             <a:extLst xmlns:a="http://schemas.openxmlformats.org/drawingml/2006/main">
               <a:ext uri="{FF2B5EF4-FFF2-40B4-BE49-F238E27FC236}">
-                <a16:creationId xmlns:a16="http://schemas.microsoft.com/office/drawing/2014/main" id="{61B738C9-91CB-4775-8261-8B4A5FD85487}"/>
+                <a16:creationId xmlns:a16="http://schemas.microsoft.com/office/drawing/2014/main" id="{6B3A44B9-A5D9-4C80-B680-2844F4173693}"/>
               </a:ext>
             </a:extLst>
           </p:cNvPr>
@@ -2830,7 +2830,7 @@
           <p:cNvPr id="3" name="Rounded-Rectangle-7-3">
             <a:extLst xmlns:a="http://schemas.openxmlformats.org/drawingml/2006/main">
               <a:ext uri="{FF2B5EF4-FFF2-40B4-BE49-F238E27FC236}">
-                <a16:creationId xmlns:a16="http://schemas.microsoft.com/office/drawing/2014/main" id="{E6DBCB1A-E894-45FF-81F4-CCD564D2EE16}"/>
+                <a16:creationId xmlns:a16="http://schemas.microsoft.com/office/drawing/2014/main" id="{3A939FB0-6499-4ADD-B5E8-38CBC6F32128}"/>
               </a:ext>
             </a:extLst>
           </p:cNvPr>
@@ -2859,7 +2859,7 @@
           <p:cNvPr id="4" name="Slide-Number-Placeholder-1-4">
             <a:extLst xmlns:a="http://schemas.openxmlformats.org/drawingml/2006/main">
               <a:ext uri="{FF2B5EF4-FFF2-40B4-BE49-F238E27FC236}">
-                <a16:creationId xmlns:a16="http://schemas.microsoft.com/office/drawing/2014/main" id="{FD619C7A-31A3-46E6-B368-A6190EA74EAF}"/>
+                <a16:creationId xmlns:a16="http://schemas.microsoft.com/office/drawing/2014/main" id="{61C7FE92-FBA7-45D7-86A0-03BFBC7DB9C1}"/>
               </a:ext>
             </a:extLst>
           </p:cNvPr>
@@ -2902,7 +2902,7 @@
           <p:cNvPr id="5" name="Title-2-5">
             <a:extLst xmlns:a="http://schemas.openxmlformats.org/drawingml/2006/main">
               <a:ext uri="{FF2B5EF4-FFF2-40B4-BE49-F238E27FC236}">
-                <a16:creationId xmlns:a16="http://schemas.microsoft.com/office/drawing/2014/main" id="{530A4893-B0B7-408A-A527-723DDCA3125E}"/>
+                <a16:creationId xmlns:a16="http://schemas.microsoft.com/office/drawing/2014/main" id="{8AEDF037-A2EF-454F-AED4-1F0E1E98BD30}"/>
               </a:ext>
             </a:extLst>
           </p:cNvPr>
@@ -2947,7 +2947,7 @@
           <p:cNvPr id="6" name="Content-Placeholder-9-6">
             <a:extLst xmlns:a="http://schemas.openxmlformats.org/drawingml/2006/main">
               <a:ext uri="{FF2B5EF4-FFF2-40B4-BE49-F238E27FC236}">
-                <a16:creationId xmlns:a16="http://schemas.microsoft.com/office/drawing/2014/main" id="{E41AF180-8C7E-4940-8954-0661D233BCA2}"/>
+                <a16:creationId xmlns:a16="http://schemas.microsoft.com/office/drawing/2014/main" id="{C2A102D6-79B2-4397-B606-1588ADADC588}"/>
               </a:ext>
             </a:extLst>
           </p:cNvPr>
@@ -2992,7 +2992,7 @@
           <p:cNvPr id="7" name="Content-Placeholder-10-7">
             <a:extLst xmlns:a="http://schemas.openxmlformats.org/drawingml/2006/main">
               <a:ext uri="{FF2B5EF4-FFF2-40B4-BE49-F238E27FC236}">
-                <a16:creationId xmlns:a16="http://schemas.microsoft.com/office/drawing/2014/main" id="{1CC65187-ABBF-4626-B30B-248B43D2255A}"/>
+                <a16:creationId xmlns:a16="http://schemas.microsoft.com/office/drawing/2014/main" id="{4F4F4D2E-82C2-4505-8DA2-7A72CCEFF7B1}"/>
               </a:ext>
             </a:extLst>
           </p:cNvPr>
@@ -3037,7 +3037,7 @@
           <p:cNvPr id="8" name="Content-Placeholder-11-8">
             <a:extLst xmlns:a="http://schemas.openxmlformats.org/drawingml/2006/main">
               <a:ext uri="{FF2B5EF4-FFF2-40B4-BE49-F238E27FC236}">
-                <a16:creationId xmlns:a16="http://schemas.microsoft.com/office/drawing/2014/main" id="{CA133300-6C2B-4A02-A400-CC195C7D17D1}"/>
+                <a16:creationId xmlns:a16="http://schemas.microsoft.com/office/drawing/2014/main" id="{3226586E-8F5C-4497-8409-F4E217466A47}"/>
               </a:ext>
             </a:extLst>
           </p:cNvPr>
@@ -3082,7 +3082,7 @@
           <p:cNvPr id="9" name="Content-Placeholder-9-9">
             <a:extLst xmlns:a="http://schemas.openxmlformats.org/drawingml/2006/main">
               <a:ext uri="{FF2B5EF4-FFF2-40B4-BE49-F238E27FC236}">
-                <a16:creationId xmlns:a16="http://schemas.microsoft.com/office/drawing/2014/main" id="{6088A9B1-4B65-4C2B-A313-35CAA23148BF}"/>
+                <a16:creationId xmlns:a16="http://schemas.microsoft.com/office/drawing/2014/main" id="{46FED8AF-9C10-436A-BB16-33DE409F9F52}"/>
               </a:ext>
             </a:extLst>
           </p:cNvPr>
@@ -3127,7 +3127,7 @@
           <p:cNvPr id="10" name="Content-Placeholder-9-10">
             <a:extLst xmlns:a="http://schemas.openxmlformats.org/drawingml/2006/main">
               <a:ext uri="{FF2B5EF4-FFF2-40B4-BE49-F238E27FC236}">
-                <a16:creationId xmlns:a16="http://schemas.microsoft.com/office/drawing/2014/main" id="{A053A5F7-BABA-4048-B652-9B24DEE754A5}"/>
+                <a16:creationId xmlns:a16="http://schemas.microsoft.com/office/drawing/2014/main" id="{4F3315B7-7864-49DF-9245-5976317F6776}"/>
               </a:ext>
             </a:extLst>
           </p:cNvPr>
@@ -3162,7 +3162,7 @@
               </a:defRPr>
             </a:pPr>
             <a:r>
-              <a:t>209</a:t>
+              <a:t>211</a:t>
             </a:r>
           </a:p>
         </p:txBody>
@@ -3172,7 +3172,7 @@
           <p:cNvPr id="11" name="Content-Placeholder-9-11">
             <a:extLst xmlns:a="http://schemas.openxmlformats.org/drawingml/2006/main">
               <a:ext uri="{FF2B5EF4-FFF2-40B4-BE49-F238E27FC236}">
-                <a16:creationId xmlns:a16="http://schemas.microsoft.com/office/drawing/2014/main" id="{14829EC8-4532-4FF2-B6C4-55A881F39130}"/>
+                <a16:creationId xmlns:a16="http://schemas.microsoft.com/office/drawing/2014/main" id="{2BDD07B4-6255-47DA-9C14-5E16079BE6BF}"/>
               </a:ext>
             </a:extLst>
           </p:cNvPr>
@@ -3217,7 +3217,7 @@
           <p:cNvPr id="12" name="Content-Placeholder-15-12">
             <a:extLst xmlns:a="http://schemas.openxmlformats.org/drawingml/2006/main">
               <a:ext uri="{FF2B5EF4-FFF2-40B4-BE49-F238E27FC236}">
-                <a16:creationId xmlns:a16="http://schemas.microsoft.com/office/drawing/2014/main" id="{57E60B0C-A1DE-4613-A955-9311B22472E1}"/>
+                <a16:creationId xmlns:a16="http://schemas.microsoft.com/office/drawing/2014/main" id="{E1CA0A85-F6DC-439C-9029-9B26DCC28B22}"/>
               </a:ext>
             </a:extLst>
           </p:cNvPr>
@@ -3275,7 +3275,7 @@
     </p:spTree>
     <p:extLst>
       <p:ext uri="{BB962C8B-B14F-4D97-AF65-F5344CB8AC3E}">
-        <p14:creationId xmlns:p14="http://schemas.microsoft.com/office/powerpoint/2010/main" val="1772312935"/>
+        <p14:creationId xmlns:p14="http://schemas.microsoft.com/office/powerpoint/2010/main" val="1698097302"/>
       </p:ext>
     </p:extLst>
   </p:cSld>
@@ -3299,7 +3299,7 @@
           <p:cNvPr id="10" name="Google-Shape-532-p58-2">
             <a:extLst xmlns:a="http://schemas.openxmlformats.org/drawingml/2006/main">
               <a:ext uri="{FF2B5EF4-FFF2-40B4-BE49-F238E27FC236}">
-                <a16:creationId xmlns:a16="http://schemas.microsoft.com/office/drawing/2014/main" id="{F2C8A358-2CED-4AE1-8684-8D883A40284A}"/>
+                <a16:creationId xmlns:a16="http://schemas.microsoft.com/office/drawing/2014/main" id="{7E28BBAE-B59D-45A7-A2F5-6C2835CB128C}"/>
               </a:ext>
             </a:extLst>
           </p:cNvPr>
@@ -3344,7 +3344,7 @@
           <p:cNvPr id="2" name="Google-Shape-533-p58-3">
             <a:extLst xmlns:a="http://schemas.openxmlformats.org/drawingml/2006/main">
               <a:ext uri="{FF2B5EF4-FFF2-40B4-BE49-F238E27FC236}">
-                <a16:creationId xmlns:a16="http://schemas.microsoft.com/office/drawing/2014/main" id="{1FA45B3A-DB30-4A2B-B6C5-41DA0C6B368A}"/>
+                <a16:creationId xmlns:a16="http://schemas.microsoft.com/office/drawing/2014/main" id="{64C4C1AD-05EB-4233-860A-6F0939921823}"/>
               </a:ext>
             </a:extLst>
           </p:cNvPr>
@@ -3389,7 +3389,7 @@
           <p:cNvPr id="3" name="Rounded-Rectangle-1-4">
             <a:extLst xmlns:a="http://schemas.openxmlformats.org/drawingml/2006/main">
               <a:ext uri="{FF2B5EF4-FFF2-40B4-BE49-F238E27FC236}">
-                <a16:creationId xmlns:a16="http://schemas.microsoft.com/office/drawing/2014/main" id="{8F1329E7-C6AC-4E25-9590-01B0AD366EAB}"/>
+                <a16:creationId xmlns:a16="http://schemas.microsoft.com/office/drawing/2014/main" id="{7E666282-7CD3-432E-804B-DCF147AA7C0E}"/>
               </a:ext>
             </a:extLst>
           </p:cNvPr>
@@ -3418,7 +3418,7 @@
           <p:cNvPr id="4" name="Content-Placeholder-10-5">
             <a:extLst xmlns:a="http://schemas.openxmlformats.org/drawingml/2006/main">
               <a:ext uri="{FF2B5EF4-FFF2-40B4-BE49-F238E27FC236}">
-                <a16:creationId xmlns:a16="http://schemas.microsoft.com/office/drawing/2014/main" id="{6B431540-3711-4565-841A-1A85C3DA0C66}"/>
+                <a16:creationId xmlns:a16="http://schemas.microsoft.com/office/drawing/2014/main" id="{17D71407-1254-4F9B-B32A-D7BE235F0965}"/>
               </a:ext>
             </a:extLst>
           </p:cNvPr>
@@ -3463,7 +3463,7 @@
           <p:cNvPr id="5" name="Content-Placeholder-15-6">
             <a:extLst xmlns:a="http://schemas.openxmlformats.org/drawingml/2006/main">
               <a:ext uri="{FF2B5EF4-FFF2-40B4-BE49-F238E27FC236}">
-                <a16:creationId xmlns:a16="http://schemas.microsoft.com/office/drawing/2014/main" id="{AC28460B-EAA4-4ECC-8BBD-CA190DB4249B}"/>
+                <a16:creationId xmlns:a16="http://schemas.microsoft.com/office/drawing/2014/main" id="{4B344210-B28F-4252-B729-337B1A7D756B}"/>
               </a:ext>
             </a:extLst>
           </p:cNvPr>
@@ -3538,7 +3538,7 @@
           <p:cNvPr id="6" name="Rounded-Rectangle-7-7">
             <a:extLst xmlns:a="http://schemas.openxmlformats.org/drawingml/2006/main">
               <a:ext uri="{FF2B5EF4-FFF2-40B4-BE49-F238E27FC236}">
-                <a16:creationId xmlns:a16="http://schemas.microsoft.com/office/drawing/2014/main" id="{7ADAE043-91EA-4DCA-BEB4-77F32BD905FF}"/>
+                <a16:creationId xmlns:a16="http://schemas.microsoft.com/office/drawing/2014/main" id="{8B22CDB1-9FBB-4846-A745-6DFFF5DA5E62}"/>
               </a:ext>
             </a:extLst>
           </p:cNvPr>
@@ -3567,7 +3567,7 @@
           <p:cNvPr id="7" name="Content-Placeholder-10-8">
             <a:extLst xmlns:a="http://schemas.openxmlformats.org/drawingml/2006/main">
               <a:ext uri="{FF2B5EF4-FFF2-40B4-BE49-F238E27FC236}">
-                <a16:creationId xmlns:a16="http://schemas.microsoft.com/office/drawing/2014/main" id="{0572B6D3-A089-45DA-8D76-F056C392EEEE}"/>
+                <a16:creationId xmlns:a16="http://schemas.microsoft.com/office/drawing/2014/main" id="{1907FCCE-35AA-4F1C-888B-CA17457C7962}"/>
               </a:ext>
             </a:extLst>
           </p:cNvPr>
@@ -3612,7 +3612,7 @@
           <p:cNvPr id="8" name="Content-Placeholder-15-9">
             <a:extLst xmlns:a="http://schemas.openxmlformats.org/drawingml/2006/main">
               <a:ext uri="{FF2B5EF4-FFF2-40B4-BE49-F238E27FC236}">
-                <a16:creationId xmlns:a16="http://schemas.microsoft.com/office/drawing/2014/main" id="{23E01ADB-5963-48F0-A89F-39AF05283A56}"/>
+                <a16:creationId xmlns:a16="http://schemas.microsoft.com/office/drawing/2014/main" id="{30A21D79-E3BE-4512-A6CB-5306AB05D2C4}"/>
               </a:ext>
             </a:extLst>
           </p:cNvPr>
@@ -3687,7 +3687,7 @@
           <p:cNvPr id="9" name="Content-Placeholder-15-10">
             <a:extLst xmlns:a="http://schemas.openxmlformats.org/drawingml/2006/main">
               <a:ext uri="{FF2B5EF4-FFF2-40B4-BE49-F238E27FC236}">
-                <a16:creationId xmlns:a16="http://schemas.microsoft.com/office/drawing/2014/main" id="{BC2F58A0-5A8F-4601-9A90-4B66AF3C1AFB}"/>
+                <a16:creationId xmlns:a16="http://schemas.microsoft.com/office/drawing/2014/main" id="{0F5086F5-3720-4FF9-841A-6A419C692BB6}"/>
               </a:ext>
             </a:extLst>
           </p:cNvPr>
@@ -3760,7 +3760,7 @@
     </p:spTree>
     <p:extLst>
       <p:ext uri="{BB962C8B-B14F-4D97-AF65-F5344CB8AC3E}">
-        <p14:creationId xmlns:p14="http://schemas.microsoft.com/office/powerpoint/2010/main" val="2057769865"/>
+        <p14:creationId xmlns:p14="http://schemas.microsoft.com/office/powerpoint/2010/main" val="1173570594"/>
       </p:ext>
     </p:extLst>
   </p:cSld>
@@ -3784,7 +3784,7 @@
           <p:cNvPr id="13" name="Slide-Number-Placeholder-3-2">
             <a:extLst xmlns:a="http://schemas.openxmlformats.org/drawingml/2006/main">
               <a:ext uri="{FF2B5EF4-FFF2-40B4-BE49-F238E27FC236}">
-                <a16:creationId xmlns:a16="http://schemas.microsoft.com/office/drawing/2014/main" id="{CE15B07C-A88B-44FF-8EC5-CF07E230DD19}"/>
+                <a16:creationId xmlns:a16="http://schemas.microsoft.com/office/drawing/2014/main" id="{E0CE2C93-E3F0-4225-B7B4-18F529DC4D0C}"/>
               </a:ext>
             </a:extLst>
           </p:cNvPr>
@@ -3827,7 +3827,7 @@
           <p:cNvPr id="2" name="Title-10-3">
             <a:extLst xmlns:a="http://schemas.openxmlformats.org/drawingml/2006/main">
               <a:ext uri="{FF2B5EF4-FFF2-40B4-BE49-F238E27FC236}">
-                <a16:creationId xmlns:a16="http://schemas.microsoft.com/office/drawing/2014/main" id="{CD6EEB58-7C90-41E6-8B50-AECA761C8B0F}"/>
+                <a16:creationId xmlns:a16="http://schemas.microsoft.com/office/drawing/2014/main" id="{6F56B586-0004-428A-8A62-0D6C8ED1070A}"/>
               </a:ext>
             </a:extLst>
           </p:cNvPr>
@@ -3894,7 +3894,7 @@
           <p:cNvPr id="4" name="Google-Shape-2260-p159-5">
             <a:extLst xmlns:a="http://schemas.openxmlformats.org/drawingml/2006/main">
               <a:ext uri="{FF2B5EF4-FFF2-40B4-BE49-F238E27FC236}">
-                <a16:creationId xmlns:a16="http://schemas.microsoft.com/office/drawing/2014/main" id="{55F5B78B-2FA7-4BA0-B019-D42B718A3F02}"/>
+                <a16:creationId xmlns:a16="http://schemas.microsoft.com/office/drawing/2014/main" id="{6BDEE5D6-02E4-4C02-B915-766B7F2D4145}"/>
               </a:ext>
             </a:extLst>
           </p:cNvPr>
@@ -3921,7 +3921,7 @@
           <p:cNvPr id="5" name="Google-Shape-2261-p159-6">
             <a:extLst xmlns:a="http://schemas.openxmlformats.org/drawingml/2006/main">
               <a:ext uri="{FF2B5EF4-FFF2-40B4-BE49-F238E27FC236}">
-                <a16:creationId xmlns:a16="http://schemas.microsoft.com/office/drawing/2014/main" id="{B8BE3E32-7A79-482B-B596-998738A724BB}"/>
+                <a16:creationId xmlns:a16="http://schemas.microsoft.com/office/drawing/2014/main" id="{FD1E6917-6DAD-4F74-8694-721ADD3F4506}"/>
               </a:ext>
             </a:extLst>
           </p:cNvPr>
@@ -3948,7 +3948,7 @@
           <p:cNvPr id="6" name="Google-Shape-2262-p159-7">
             <a:extLst xmlns:a="http://schemas.openxmlformats.org/drawingml/2006/main">
               <a:ext uri="{FF2B5EF4-FFF2-40B4-BE49-F238E27FC236}">
-                <a16:creationId xmlns:a16="http://schemas.microsoft.com/office/drawing/2014/main" id="{DD3C2C90-8B3E-4353-B393-D7CE0A1AD7BB}"/>
+                <a16:creationId xmlns:a16="http://schemas.microsoft.com/office/drawing/2014/main" id="{2CD128B6-4BF3-4D40-99F8-B09EDC7C31FB}"/>
               </a:ext>
             </a:extLst>
           </p:cNvPr>
@@ -3975,7 +3975,7 @@
           <p:cNvPr id="7" name="Content-Placeholder-15-8">
             <a:extLst xmlns:a="http://schemas.openxmlformats.org/drawingml/2006/main">
               <a:ext uri="{FF2B5EF4-FFF2-40B4-BE49-F238E27FC236}">
-                <a16:creationId xmlns:a16="http://schemas.microsoft.com/office/drawing/2014/main" id="{6DBF4FB0-5B1E-4D2E-ADAE-D81810948222}"/>
+                <a16:creationId xmlns:a16="http://schemas.microsoft.com/office/drawing/2014/main" id="{BAF48B5B-DE6C-4FCC-B493-4E4F323F823E}"/>
               </a:ext>
             </a:extLst>
           </p:cNvPr>
@@ -4020,7 +4020,7 @@
           <p:cNvPr id="8" name="Content-Placeholder-15-9">
             <a:extLst xmlns:a="http://schemas.openxmlformats.org/drawingml/2006/main">
               <a:ext uri="{FF2B5EF4-FFF2-40B4-BE49-F238E27FC236}">
-                <a16:creationId xmlns:a16="http://schemas.microsoft.com/office/drawing/2014/main" id="{FA5916C5-263D-4BB8-9BC4-476076B7B5C8}"/>
+                <a16:creationId xmlns:a16="http://schemas.microsoft.com/office/drawing/2014/main" id="{BF26DA1B-83A5-4BF8-ADEF-BA2D6EDEF5D7}"/>
               </a:ext>
             </a:extLst>
           </p:cNvPr>
@@ -4065,7 +4065,7 @@
           <p:cNvPr id="9" name="Content-Placeholder-15-10">
             <a:extLst xmlns:a="http://schemas.openxmlformats.org/drawingml/2006/main">
               <a:ext uri="{FF2B5EF4-FFF2-40B4-BE49-F238E27FC236}">
-                <a16:creationId xmlns:a16="http://schemas.microsoft.com/office/drawing/2014/main" id="{B382BC17-3440-4261-8A1B-5257C4317E56}"/>
+                <a16:creationId xmlns:a16="http://schemas.microsoft.com/office/drawing/2014/main" id="{49CFE180-8003-4CCE-A653-793324EB3219}"/>
               </a:ext>
             </a:extLst>
           </p:cNvPr>
@@ -4110,7 +4110,7 @@
           <p:cNvPr id="10" name="Text-Placeholder-16-11">
             <a:extLst xmlns:a="http://schemas.openxmlformats.org/drawingml/2006/main">
               <a:ext uri="{FF2B5EF4-FFF2-40B4-BE49-F238E27FC236}">
-                <a16:creationId xmlns:a16="http://schemas.microsoft.com/office/drawing/2014/main" id="{72BB1B6E-24CE-4880-91FF-7A6D55DC6A7B}"/>
+                <a16:creationId xmlns:a16="http://schemas.microsoft.com/office/drawing/2014/main" id="{2355C4A5-A909-4538-8C34-914C7831EC66}"/>
               </a:ext>
             </a:extLst>
           </p:cNvPr>
@@ -4170,7 +4170,7 @@
           <p:cNvPr id="11" name="Text-Placeholder-16-12">
             <a:extLst xmlns:a="http://schemas.openxmlformats.org/drawingml/2006/main">
               <a:ext uri="{FF2B5EF4-FFF2-40B4-BE49-F238E27FC236}">
-                <a16:creationId xmlns:a16="http://schemas.microsoft.com/office/drawing/2014/main" id="{D3620E7B-D830-4FE9-A4B6-8604AAB3032B}"/>
+                <a16:creationId xmlns:a16="http://schemas.microsoft.com/office/drawing/2014/main" id="{D82FF974-785B-4772-9C92-DF4FB03C7B00}"/>
               </a:ext>
             </a:extLst>
           </p:cNvPr>
@@ -4230,7 +4230,7 @@
           <p:cNvPr id="12" name="Text-Placeholder-16-13">
             <a:extLst xmlns:a="http://schemas.openxmlformats.org/drawingml/2006/main">
               <a:ext uri="{FF2B5EF4-FFF2-40B4-BE49-F238E27FC236}">
-                <a16:creationId xmlns:a16="http://schemas.microsoft.com/office/drawing/2014/main" id="{0DFDAAF0-D027-421C-A6CE-3F1740249E7D}"/>
+                <a16:creationId xmlns:a16="http://schemas.microsoft.com/office/drawing/2014/main" id="{9E096570-0ED1-4B06-871F-87D3AA6DE3B8}"/>
               </a:ext>
             </a:extLst>
           </p:cNvPr>
@@ -4288,7 +4288,7 @@
     </p:spTree>
     <p:extLst>
       <p:ext uri="{BB962C8B-B14F-4D97-AF65-F5344CB8AC3E}">
-        <p14:creationId xmlns:p14="http://schemas.microsoft.com/office/powerpoint/2010/main" val="1349016710"/>
+        <p14:creationId xmlns:p14="http://schemas.microsoft.com/office/powerpoint/2010/main" val="67226441"/>
       </p:ext>
     </p:extLst>
   </p:cSld>

</xml_diff>